<commit_message>
Add beta usage, approval email queue, richer feedback, and illustrated previews
</commit_message>
<xml_diff>
--- a/public/previews/v1/food-at-a-restaurant.pptx
+++ b/public/previews/v1/food-at-a-restaurant.pptx
@@ -5,7 +5,7 @@
     <p:sldMasterId id="2147483648" r:id="rId1"/>
   </p:sldMasterIdLst>
   <p:notesMasterIdLst>
-    <p:notesMasterId r:id="rId17"/>
+    <p:notesMasterId r:id="rId18"/>
   </p:notesMasterIdLst>
   <p:sldIdLst>
     <p:sldId id="256" r:id="rId2"/>
@@ -23,6 +23,7 @@
     <p:sldId id="268" r:id="rId14"/>
     <p:sldId id="269" r:id="rId15"/>
     <p:sldId id="270" r:id="rId16"/>
+    <p:sldId id="271" r:id="rId17"/>
   </p:sldIdLst>
   <p:sldSz cx="9144000" cy="5143500"/>
   <p:notesSz cx="5143500" cy="9144000"/>
@@ -1068,6 +1069,94 @@
             <a:fld id="{F7021451-1387-4CA6-816F-3879F97B5CBC}" type="slidenum">
               <a:rPr lang="en-US"/>
               <a:t>15</a:t>
+            </a:fld>
+            <a:endParaRPr lang="en-US"/>
+          </a:p>
+        </p:txBody>
+      </p:sp>
+    </p:spTree>
+    <p:extLst>
+      <p:ext uri="{BB962C8B-B14F-4D97-AF65-F5344CB8AC3E}">
+        <p14:creationId xmlns:p14="http://schemas.microsoft.com/office/powerpoint/2010/main" val="1024086991"/>
+      </p:ext>
+    </p:extLst>
+  </p:cSld>
+  <p:clrMapOvr>
+    <a:masterClrMapping/>
+  </p:clrMapOvr>
+</p:notes>
+</file>
+
+<file path=ppt/notesSlides/notesSlide16.xml><?xml version="1.0" encoding="utf-8"?>
+<p:notes xmlns:a="http://schemas.openxmlformats.org/drawingml/2006/main" xmlns:r="http://schemas.openxmlformats.org/officeDocument/2006/relationships" xmlns:p="http://schemas.openxmlformats.org/presentationml/2006/main">
+  <p:cSld>
+    <p:spTree>
+      <p:nvGrpSpPr>
+        <p:cNvPr id="1" name=""/>
+        <p:cNvGrpSpPr/>
+        <p:nvPr/>
+      </p:nvGrpSpPr>
+      <p:grpSpPr>
+        <a:xfrm>
+          <a:off x="0" y="0"/>
+          <a:ext cx="0" cy="0"/>
+          <a:chOff x="0" y="0"/>
+          <a:chExt cx="0" cy="0"/>
+        </a:xfrm>
+      </p:grpSpPr>
+      <p:sp>
+        <p:nvSpPr>
+          <p:cNvPr id="2" name="Slide Image Placeholder 1"/>
+          <p:cNvSpPr>
+            <a:spLocks noGrp="1" noRot="1" noChangeAspect="1"/>
+          </p:cNvSpPr>
+          <p:nvPr>
+            <p:ph type="sldImg"/>
+          </p:nvPr>
+        </p:nvSpPr>
+        <p:spPr/>
+      </p:sp>
+      <p:sp>
+        <p:nvSpPr>
+          <p:cNvPr id="3" name="Notes Placeholder 2"/>
+          <p:cNvSpPr>
+            <a:spLocks noGrp="1"/>
+          </p:cNvSpPr>
+          <p:nvPr>
+            <p:ph type="body" idx="1"/>
+          </p:nvPr>
+        </p:nvSpPr>
+        <p:spPr/>
+        <p:txBody>
+          <a:bodyPr/>
+          <a:lstStyle/>
+          <a:p>
+            <a:r>
+              <a:rPr lang="en-US" dirty="0"/>
+              <a:t/>
+            </a:r>
+            <a:endParaRPr lang="en-US" dirty="0"/>
+          </a:p>
+        </p:txBody>
+      </p:sp>
+      <p:sp>
+        <p:nvSpPr>
+          <p:cNvPr id="4" name="Slide Number Placeholder 3"/>
+          <p:cNvSpPr>
+            <a:spLocks noGrp="1"/>
+          </p:cNvSpPr>
+          <p:nvPr>
+            <p:ph type="sldNum" sz="quarter" idx="10"/>
+          </p:nvPr>
+        </p:nvSpPr>
+        <p:spPr/>
+        <p:txBody>
+          <a:bodyPr/>
+          <a:lstStyle/>
+          <a:p>
+            <a:fld id="{F7021451-1387-4CA6-816F-3879F97B5CBC}" type="slidenum">
+              <a:rPr lang="en-US"/>
+              <a:t>16</a:t>
             </a:fld>
             <a:endParaRPr lang="en-US"/>
           </a:p>
@@ -2349,7 +2438,7 @@
                 <a:ea typeface="Georgia" pitchFamily="34" charset="-122"/>
                 <a:cs typeface="Georgia" pitchFamily="34" charset="-120"/>
               </a:rPr>
-              <a:t>Listen for details</a:t>
+              <a:t>Read and notice</a:t>
             </a:r>
             <a:endParaRPr lang="en-US" sz="3000" dirty="0"/>
           </a:p>
@@ -2421,7 +2510,7 @@
                 <a:ea typeface="Calibri" pitchFamily="34" charset="-122"/>
                 <a:cs typeface="Calibri" pitchFamily="34" charset="-120"/>
               </a:rPr>
-              <a:t>A Changed Order</a:t>
+              <a:t>Lunch at Cedar Café</a:t>
             </a:r>
             <a:endParaRPr lang="en-US" sz="1900" dirty="0"/>
           </a:p>
@@ -2489,7 +2578,7 @@
                 <a:ea typeface="Calibri" pitchFamily="34" charset="-122"/>
                 <a:cs typeface="Calibri" pitchFamily="34" charset="-120"/>
               </a:rPr>
-              <a:t>Listen once for the situation, then again for details.</a:t>
+              <a:t>Which food is unavailable?</a:t>
             </a:r>
             <a:endParaRPr lang="en-US" sz="1500" dirty="0"/>
           </a:p>
@@ -2621,7 +2710,7 @@
                 <a:ea typeface="Georgia" pitchFamily="34" charset="-122"/>
                 <a:cs typeface="Georgia" pitchFamily="34" charset="-120"/>
               </a:rPr>
-              <a:t>Useful language</a:t>
+              <a:t>Listen for details</a:t>
             </a:r>
             <a:endParaRPr lang="en-US" sz="3000" dirty="0"/>
           </a:p>
@@ -2675,15 +2764,14 @@
           </a:bodyPr>
           <a:lstStyle/>
           <a:p>
-            <a:pPr algn="just" marL="342900" indent="-342900">
+            <a:pPr algn="just" indent="0" marL="0">
               <a:lnSpc>
                 <a:spcPct val="115000"/>
               </a:lnSpc>
               <a:spcAft>
                 <a:spcPts val="1200"/>
               </a:spcAft>
-              <a:buSzPct val="100000"/>
-              <a:buChar char="•"/>
+              <a:buNone/>
             </a:pPr>
             <a:r>
               <a:rPr lang="en-US" sz="1900" dirty="0">
@@ -2694,55 +2782,7 @@
                 <a:ea typeface="Calibri" pitchFamily="34" charset="-122"/>
                 <a:cs typeface="Calibri" pitchFamily="34" charset="-120"/>
               </a:rPr>
-              <a:t>I would like ___, please.</a:t>
-            </a:r>
-            <a:endParaRPr lang="en-US" sz="1900" dirty="0"/>
-          </a:p>
-          <a:p>
-            <a:pPr algn="just" marL="342900" indent="-342900">
-              <a:lnSpc>
-                <a:spcPct val="115000"/>
-              </a:lnSpc>
-              <a:spcAft>
-                <a:spcPts val="1200"/>
-              </a:spcAft>
-              <a:buSzPct val="100000"/>
-              <a:buChar char="•"/>
-            </a:pPr>
-            <a:r>
-              <a:rPr lang="en-US" sz="1900" dirty="0">
-                <a:solidFill>
-                  <a:srgbClr val="1C2B2D"/>
-                </a:solidFill>
-                <a:latin typeface="Calibri" pitchFamily="34" charset="0"/>
-                <a:ea typeface="Calibri" pitchFamily="34" charset="-122"/>
-                <a:cs typeface="Calibri" pitchFamily="34" charset="-120"/>
-              </a:rPr>
-              <a:t>Do you have ___?</a:t>
-            </a:r>
-            <a:endParaRPr lang="en-US" sz="1900" dirty="0"/>
-          </a:p>
-          <a:p>
-            <a:pPr algn="just" marL="342900" indent="-342900">
-              <a:lnSpc>
-                <a:spcPct val="115000"/>
-              </a:lnSpc>
-              <a:spcAft>
-                <a:spcPts val="1200"/>
-              </a:spcAft>
-              <a:buSzPct val="100000"/>
-              <a:buChar char="•"/>
-            </a:pPr>
-            <a:r>
-              <a:rPr lang="en-US" sz="1900" dirty="0">
-                <a:solidFill>
-                  <a:srgbClr val="1C2B2D"/>
-                </a:solidFill>
-                <a:latin typeface="Calibri" pitchFamily="34" charset="0"/>
-                <a:ea typeface="Calibri" pitchFamily="34" charset="-122"/>
-                <a:cs typeface="Calibri" pitchFamily="34" charset="-120"/>
-              </a:rPr>
-              <a:t>Could I have the bill, please?</a:t>
+              <a:t>A Changed Order</a:t>
             </a:r>
             <a:endParaRPr lang="en-US" sz="1900" dirty="0"/>
           </a:p>
@@ -2810,7 +2850,7 @@
                 <a:ea typeface="Calibri" pitchFamily="34" charset="-122"/>
                 <a:cs typeface="Calibri" pitchFamily="34" charset="-120"/>
               </a:rPr>
-              <a:t>Adapt one frame to the situation.</a:t>
+              <a:t>Listen once for the situation, then again for details.</a:t>
             </a:r>
             <a:endParaRPr lang="en-US" sz="1500" dirty="0"/>
           </a:p>
@@ -2942,7 +2982,7 @@
                 <a:ea typeface="Georgia" pitchFamily="34" charset="-122"/>
                 <a:cs typeface="Georgia" pitchFamily="34" charset="-120"/>
               </a:rPr>
-              <a:t>Cedar Café role-play · 1</a:t>
+              <a:t>Useful language</a:t>
             </a:r>
             <a:endParaRPr lang="en-US" sz="3000" dirty="0"/>
           </a:p>
@@ -2996,14 +3036,15 @@
           </a:bodyPr>
           <a:lstStyle/>
           <a:p>
-            <a:pPr algn="just" indent="0" marL="0">
+            <a:pPr algn="just" marL="342900" indent="-342900">
               <a:lnSpc>
                 <a:spcPct val="115000"/>
               </a:lnSpc>
               <a:spcAft>
                 <a:spcPts val="1200"/>
               </a:spcAft>
-              <a:buNone/>
+              <a:buSzPct val="100000"/>
+              <a:buChar char="•"/>
             </a:pPr>
             <a:r>
               <a:rPr lang="en-US" sz="1900" dirty="0">
@@ -3014,7 +3055,55 @@
                 <a:ea typeface="Calibri" pitchFamily="34" charset="-122"/>
                 <a:cs typeface="Calibri" pitchFamily="34" charset="-120"/>
               </a:rPr>
-              <a:t>Menu: Chicken with rice $12; vegetable soup $6; bean sandwich $7; water $2; orange juice $3. Prices include all charges for this fictional activity.</a:t>
+              <a:t>I would like ___, please.</a:t>
+            </a:r>
+            <a:endParaRPr lang="en-US" sz="1900" dirty="0"/>
+          </a:p>
+          <a:p>
+            <a:pPr algn="just" marL="342900" indent="-342900">
+              <a:lnSpc>
+                <a:spcPct val="115000"/>
+              </a:lnSpc>
+              <a:spcAft>
+                <a:spcPts val="1200"/>
+              </a:spcAft>
+              <a:buSzPct val="100000"/>
+              <a:buChar char="•"/>
+            </a:pPr>
+            <a:r>
+              <a:rPr lang="en-US" sz="1900" dirty="0">
+                <a:solidFill>
+                  <a:srgbClr val="1C2B2D"/>
+                </a:solidFill>
+                <a:latin typeface="Calibri" pitchFamily="34" charset="0"/>
+                <a:ea typeface="Calibri" pitchFamily="34" charset="-122"/>
+                <a:cs typeface="Calibri" pitchFamily="34" charset="-120"/>
+              </a:rPr>
+              <a:t>Do you have ___?</a:t>
+            </a:r>
+            <a:endParaRPr lang="en-US" sz="1900" dirty="0"/>
+          </a:p>
+          <a:p>
+            <a:pPr algn="just" marL="342900" indent="-342900">
+              <a:lnSpc>
+                <a:spcPct val="115000"/>
+              </a:lnSpc>
+              <a:spcAft>
+                <a:spcPts val="1200"/>
+              </a:spcAft>
+              <a:buSzPct val="100000"/>
+              <a:buChar char="•"/>
+            </a:pPr>
+            <a:r>
+              <a:rPr lang="en-US" sz="1900" dirty="0">
+                <a:solidFill>
+                  <a:srgbClr val="1C2B2D"/>
+                </a:solidFill>
+                <a:latin typeface="Calibri" pitchFamily="34" charset="0"/>
+                <a:ea typeface="Calibri" pitchFamily="34" charset="-122"/>
+                <a:cs typeface="Calibri" pitchFamily="34" charset="-120"/>
+              </a:rPr>
+              <a:t>Could I have the bill, please?</a:t>
             </a:r>
             <a:endParaRPr lang="en-US" sz="1900" dirty="0"/>
           </a:p>
@@ -3082,7 +3171,7 @@
                 <a:ea typeface="Calibri" pitchFamily="34" charset="-122"/>
                 <a:cs typeface="Calibri" pitchFamily="34" charset="-120"/>
               </a:rPr>
-              <a:t>Discuss your choice and explain your reason.</a:t>
+              <a:t>Adapt one frame to the situation.</a:t>
             </a:r>
             <a:endParaRPr lang="en-US" sz="1500" dirty="0"/>
           </a:p>
@@ -3214,7 +3303,7 @@
                 <a:ea typeface="Georgia" pitchFamily="34" charset="-122"/>
                 <a:cs typeface="Georgia" pitchFamily="34" charset="-120"/>
               </a:rPr>
-              <a:t>Cedar Café role-play · 2</a:t>
+              <a:t>Cedar Café role-play · 1</a:t>
             </a:r>
             <a:endParaRPr lang="en-US" sz="3000" dirty="0"/>
           </a:p>
@@ -3286,7 +3375,7 @@
                 <a:ea typeface="Calibri" pitchFamily="34" charset="-122"/>
                 <a:cs typeface="Calibri" pitchFamily="34" charset="-120"/>
               </a:rPr>
-              <a:t>Customer: You have $15. Order food and a drink. Ask for the bill and check it.</a:t>
+              <a:t>Menu: Chicken with rice $12; vegetable soup $6; bean sandwich $7; water $2; orange juice $3. Prices include all charges for this fictional activity.</a:t>
             </a:r>
             <a:endParaRPr lang="en-US" sz="1900" dirty="0"/>
           </a:p>
@@ -3486,7 +3575,7 @@
                 <a:ea typeface="Georgia" pitchFamily="34" charset="-122"/>
                 <a:cs typeface="Georgia" pitchFamily="34" charset="-120"/>
               </a:rPr>
-              <a:t>Cedar Café role-play · 3</a:t>
+              <a:t>Cedar Café role-play · 2</a:t>
             </a:r>
             <a:endParaRPr lang="en-US" sz="3000" dirty="0"/>
           </a:p>
@@ -3558,7 +3647,7 @@
                 <a:ea typeface="Calibri" pitchFamily="34" charset="-122"/>
                 <a:cs typeface="Calibri" pitchFamily="34" charset="-120"/>
               </a:rPr>
-              <a:t>Server: Soup is unavailable. Offer another dish. Repeat the order and calculate the total.</a:t>
+              <a:t>Customer: You have $15. Order food and a drink. Ask for the bill and check it.</a:t>
             </a:r>
             <a:endParaRPr lang="en-US" sz="1900" dirty="0"/>
           </a:p>
@@ -3758,7 +3847,7 @@
                 <a:ea typeface="Georgia" pitchFamily="34" charset="-122"/>
                 <a:cs typeface="Georgia" pitchFamily="34" charset="-120"/>
               </a:rPr>
-              <a:t>Your final response</a:t>
+              <a:t>Cedar Café role-play · 3</a:t>
             </a:r>
             <a:endParaRPr lang="en-US" sz="3000" dirty="0"/>
           </a:p>
@@ -3830,7 +3919,7 @@
                 <a:ea typeface="Calibri" pitchFamily="34" charset="-122"/>
                 <a:cs typeface="Calibri" pitchFamily="34" charset="-120"/>
               </a:rPr>
-              <a:t>Order food and a drink. Ask for the bill.</a:t>
+              <a:t>Server: Soup is unavailable. Offer another dish. Repeat the order and calculate the total.</a:t>
             </a:r>
             <a:endParaRPr lang="en-US" sz="1900" dirty="0"/>
           </a:p>
@@ -3898,7 +3987,7 @@
                 <a:ea typeface="Calibri" pitchFamily="34" charset="-122"/>
                 <a:cs typeface="Calibri" pitchFamily="34" charset="-120"/>
               </a:rPr>
-              <a:t>Check the total. Thank the server.</a:t>
+              <a:t>Discuss your choice and explain your reason.</a:t>
             </a:r>
             <a:endParaRPr lang="en-US" sz="1500" dirty="0"/>
           </a:p>
@@ -3938,6 +4027,278 @@
                 <a:cs typeface="Calibri" pitchFamily="34" charset="-120"/>
               </a:rPr>
               <a:t>14</a:t>
+            </a:r>
+            <a:endParaRPr lang="en-US" sz="1100" dirty="0"/>
+          </a:p>
+        </p:txBody>
+      </p:sp>
+    </p:spTree>
+  </p:cSld>
+  <p:clrMapOvr>
+    <a:masterClrMapping/>
+  </p:clrMapOvr>
+</p:sld>
+</file>
+
+<file path=ppt/slides/slide16.xml><?xml version="1.0" encoding="utf-8"?>
+<p:sld xmlns:a="http://schemas.openxmlformats.org/drawingml/2006/main" xmlns:r="http://schemas.openxmlformats.org/officeDocument/2006/relationships" xmlns:p="http://schemas.openxmlformats.org/presentationml/2006/main">
+  <p:cSld name="Slide 16">
+    <p:bg>
+      <p:bgPr>
+        <a:solidFill>
+          <a:srgbClr val="FFFFFF"/>
+        </a:solidFill>
+      </p:bgPr>
+    </p:bg>
+    <p:spTree>
+      <p:nvGrpSpPr>
+        <p:cNvPr id="1" name=""/>
+        <p:cNvGrpSpPr/>
+        <p:nvPr/>
+      </p:nvGrpSpPr>
+      <p:grpSpPr>
+        <a:xfrm>
+          <a:off x="0" y="0"/>
+          <a:ext cx="0" cy="0"/>
+          <a:chOff x="0" y="0"/>
+          <a:chExt cx="0" cy="0"/>
+        </a:xfrm>
+      </p:grpSpPr>
+      <p:sp>
+        <p:nvSpPr>
+          <p:cNvPr id="2" name="Shape 0"/>
+          <p:cNvSpPr/>
+          <p:nvPr/>
+        </p:nvSpPr>
+        <p:spPr>
+          <a:xfrm>
+            <a:off x="0" y="0"/>
+            <a:ext cx="9144000" cy="164592"/>
+          </a:xfrm>
+          <a:prstGeom prst="rect">
+            <a:avLst/>
+          </a:prstGeom>
+          <a:solidFill>
+            <a:srgbClr val="0F766E"/>
+          </a:solidFill>
+          <a:ln/>
+        </p:spPr>
+      </p:sp>
+      <p:sp>
+        <p:nvSpPr>
+          <p:cNvPr id="3" name="Text 1"/>
+          <p:cNvSpPr/>
+          <p:nvPr/>
+        </p:nvSpPr>
+        <p:spPr>
+          <a:xfrm>
+            <a:off x="502920" y="347472"/>
+            <a:ext cx="7680960" cy="777240"/>
+          </a:xfrm>
+          <a:prstGeom prst="rect">
+            <a:avLst/>
+          </a:prstGeom>
+          <a:noFill/>
+          <a:ln/>
+        </p:spPr>
+        <p:txBody>
+          <a:bodyPr wrap="square" rtlCol="0" anchor="ctr">
+            <a:normAutofit/>
+          </a:bodyPr>
+          <a:lstStyle/>
+          <a:p>
+            <a:pPr indent="0" marL="0">
+              <a:buNone/>
+            </a:pPr>
+            <a:r>
+              <a:rPr lang="en-US" sz="3000" b="1" dirty="0">
+                <a:solidFill>
+                  <a:srgbClr val="10312B"/>
+                </a:solidFill>
+                <a:latin typeface="Georgia" pitchFamily="34" charset="0"/>
+                <a:ea typeface="Georgia" pitchFamily="34" charset="-122"/>
+                <a:cs typeface="Georgia" pitchFamily="34" charset="-120"/>
+              </a:rPr>
+              <a:t>Your final response</a:t>
+            </a:r>
+            <a:endParaRPr lang="en-US" sz="3000" dirty="0"/>
+          </a:p>
+        </p:txBody>
+      </p:sp>
+      <p:sp>
+        <p:nvSpPr>
+          <p:cNvPr id="4" name="Shape 2"/>
+          <p:cNvSpPr/>
+          <p:nvPr/>
+        </p:nvSpPr>
+        <p:spPr>
+          <a:xfrm>
+            <a:off x="502920" y="1234440"/>
+            <a:ext cx="8138160" cy="2583180"/>
+          </a:xfrm>
+          <a:prstGeom prst="rect">
+            <a:avLst/>
+          </a:prstGeom>
+          <a:solidFill>
+            <a:srgbClr val="F6F5F1"/>
+          </a:solidFill>
+          <a:ln w="12700">
+            <a:solidFill>
+              <a:srgbClr val="F6F5F1"/>
+            </a:solidFill>
+            <a:prstDash val="solid"/>
+          </a:ln>
+        </p:spPr>
+      </p:sp>
+      <p:sp>
+        <p:nvSpPr>
+          <p:cNvPr id="5" name="Text 3"/>
+          <p:cNvSpPr/>
+          <p:nvPr/>
+        </p:nvSpPr>
+        <p:spPr>
+          <a:xfrm>
+            <a:off x="777240" y="1435608"/>
+            <a:ext cx="7589520" cy="2180844"/>
+          </a:xfrm>
+          <a:prstGeom prst="rect">
+            <a:avLst/>
+          </a:prstGeom>
+          <a:noFill/>
+          <a:ln/>
+        </p:spPr>
+        <p:txBody>
+          <a:bodyPr wrap="square" lIns="0" tIns="0" rIns="0" bIns="0" rtlCol="0" anchor="t">
+            <a:normAutofit/>
+          </a:bodyPr>
+          <a:lstStyle/>
+          <a:p>
+            <a:pPr algn="just" indent="0" marL="0">
+              <a:lnSpc>
+                <a:spcPct val="115000"/>
+              </a:lnSpc>
+              <a:spcAft>
+                <a:spcPts val="1200"/>
+              </a:spcAft>
+              <a:buNone/>
+            </a:pPr>
+            <a:r>
+              <a:rPr lang="en-US" sz="1900" dirty="0">
+                <a:solidFill>
+                  <a:srgbClr val="1C2B2D"/>
+                </a:solidFill>
+                <a:latin typeface="Calibri" pitchFamily="34" charset="0"/>
+                <a:ea typeface="Calibri" pitchFamily="34" charset="-122"/>
+                <a:cs typeface="Calibri" pitchFamily="34" charset="-120"/>
+              </a:rPr>
+              <a:t>Order food and a drink. Ask for the bill.</a:t>
+            </a:r>
+            <a:endParaRPr lang="en-US" sz="1900" dirty="0"/>
+          </a:p>
+        </p:txBody>
+      </p:sp>
+      <p:sp>
+        <p:nvSpPr>
+          <p:cNvPr id="6" name="Shape 4"/>
+          <p:cNvSpPr/>
+          <p:nvPr/>
+        </p:nvSpPr>
+        <p:spPr>
+          <a:xfrm>
+            <a:off x="502920" y="3973068"/>
+            <a:ext cx="8138160" cy="731520"/>
+          </a:xfrm>
+          <a:prstGeom prst="roundRect">
+            <a:avLst>
+              <a:gd name="adj" fmla="val 10000"/>
+            </a:avLst>
+          </a:prstGeom>
+          <a:solidFill>
+            <a:srgbClr val="E3EFEC"/>
+          </a:solidFill>
+          <a:ln w="12700">
+            <a:solidFill>
+              <a:srgbClr val="0F766E"/>
+            </a:solidFill>
+            <a:prstDash val="solid"/>
+          </a:ln>
+        </p:spPr>
+      </p:sp>
+      <p:sp>
+        <p:nvSpPr>
+          <p:cNvPr id="7" name="Text 5"/>
+          <p:cNvSpPr/>
+          <p:nvPr/>
+        </p:nvSpPr>
+        <p:spPr>
+          <a:xfrm>
+            <a:off x="685800" y="4027932"/>
+            <a:ext cx="7772400" cy="621792"/>
+          </a:xfrm>
+          <a:prstGeom prst="rect">
+            <a:avLst/>
+          </a:prstGeom>
+          <a:noFill/>
+          <a:ln/>
+        </p:spPr>
+        <p:txBody>
+          <a:bodyPr wrap="square" rtlCol="0" anchor="ctr">
+            <a:normAutofit/>
+          </a:bodyPr>
+          <a:lstStyle/>
+          <a:p>
+            <a:pPr algn="just" indent="0" marL="0">
+              <a:buNone/>
+            </a:pPr>
+            <a:r>
+              <a:rPr lang="en-US" sz="1500" b="1" dirty="0">
+                <a:solidFill>
+                  <a:srgbClr val="10312B"/>
+                </a:solidFill>
+                <a:latin typeface="Calibri" pitchFamily="34" charset="0"/>
+                <a:ea typeface="Calibri" pitchFamily="34" charset="-122"/>
+                <a:cs typeface="Calibri" pitchFamily="34" charset="-120"/>
+              </a:rPr>
+              <a:t>Check the total. Thank the server.</a:t>
+            </a:r>
+            <a:endParaRPr lang="en-US" sz="1500" dirty="0"/>
+          </a:p>
+        </p:txBody>
+      </p:sp>
+      <p:sp>
+        <p:nvSpPr>
+          <p:cNvPr id="8" name="Text 6"/>
+          <p:cNvSpPr/>
+          <p:nvPr/>
+        </p:nvSpPr>
+        <p:spPr>
+          <a:xfrm>
+            <a:off x="8458200" y="4732020"/>
+            <a:ext cx="457200" cy="292608"/>
+          </a:xfrm>
+          <a:prstGeom prst="rect">
+            <a:avLst/>
+          </a:prstGeom>
+          <a:noFill/>
+          <a:ln/>
+        </p:spPr>
+        <p:txBody>
+          <a:bodyPr wrap="square" rtlCol="0" anchor="ctr"/>
+          <a:lstStyle/>
+          <a:p>
+            <a:pPr algn="r" indent="0" marL="0">
+              <a:buNone/>
+            </a:pPr>
+            <a:r>
+              <a:rPr lang="en-US" sz="1100" dirty="0">
+                <a:solidFill>
+                  <a:srgbClr val="6B7B79"/>
+                </a:solidFill>
+                <a:latin typeface="Calibri" pitchFamily="34" charset="0"/>
+                <a:ea typeface="Calibri" pitchFamily="34" charset="-122"/>
+                <a:cs typeface="Calibri" pitchFamily="34" charset="-120"/>
+              </a:rPr>
+              <a:t>15</a:t>
             </a:r>
             <a:endParaRPr lang="en-US" sz="1100" dirty="0"/>
           </a:p>
@@ -4574,7 +4935,7 @@
                 <a:ea typeface="Georgia" pitchFamily="34" charset="-122"/>
                 <a:cs typeface="Georgia" pitchFamily="34" charset="-120"/>
               </a:rPr>
-              <a:t>Menu</a:t>
+              <a:t>Look and discuss</a:t>
             </a:r>
             <a:endParaRPr lang="en-US" sz="3000" dirty="0"/>
           </a:p>
@@ -4589,7 +4950,7 @@
         <p:spPr>
           <a:xfrm>
             <a:off x="502920" y="1234440"/>
-            <a:ext cx="8138160" cy="2583180"/>
+            <a:ext cx="4557370" cy="3406140"/>
           </a:xfrm>
           <a:prstGeom prst="rect">
             <a:avLst/>
@@ -4613,67 +4974,32 @@
         </p:nvSpPr>
         <p:spPr>
           <a:xfrm>
-            <a:off x="777240" y="1399032"/>
-            <a:ext cx="7589520" cy="685800"/>
-          </a:xfrm>
-          <a:prstGeom prst="rect">
-            <a:avLst/>
-          </a:prstGeom>
-          <a:noFill/>
-          <a:ln/>
-        </p:spPr>
-        <p:txBody>
-          <a:bodyPr wrap="square" rtlCol="0" anchor="ctr">
+            <a:off x="777240" y="1435608"/>
+            <a:ext cx="4008730" cy="3003804"/>
+          </a:xfrm>
+          <a:prstGeom prst="rect">
+            <a:avLst/>
+          </a:prstGeom>
+          <a:noFill/>
+          <a:ln/>
+        </p:spPr>
+        <p:txBody>
+          <a:bodyPr wrap="square" lIns="0" tIns="0" rIns="0" bIns="0" rtlCol="0" anchor="t">
             <a:normAutofit/>
           </a:bodyPr>
           <a:lstStyle/>
           <a:p>
-            <a:pPr indent="0" marL="0">
+            <a:pPr algn="just" indent="0" marL="0">
+              <a:lnSpc>
+                <a:spcPct val="115000"/>
+              </a:lnSpc>
+              <a:spcAft>
+                <a:spcPts val="1200"/>
+              </a:spcAft>
               <a:buNone/>
             </a:pPr>
             <a:r>
-              <a:rPr lang="en-US" sz="3400" b="1" dirty="0">
-                <a:solidFill>
-                  <a:srgbClr val="C1272D"/>
-                </a:solidFill>
-                <a:latin typeface="Georgia" pitchFamily="34" charset="0"/>
-                <a:ea typeface="Georgia" pitchFamily="34" charset="-122"/>
-                <a:cs typeface="Georgia" pitchFamily="34" charset="-120"/>
-              </a:rPr>
-              <a:t>Menu</a:t>
-            </a:r>
-            <a:endParaRPr lang="en-US" sz="3400" dirty="0"/>
-          </a:p>
-        </p:txBody>
-      </p:sp>
-      <p:sp>
-        <p:nvSpPr>
-          <p:cNvPr id="6" name="Text 4"/>
-          <p:cNvSpPr/>
-          <p:nvPr/>
-        </p:nvSpPr>
-        <p:spPr>
-          <a:xfrm>
-            <a:off x="777240" y="2148840"/>
-            <a:ext cx="7589520" cy="845820"/>
-          </a:xfrm>
-          <a:prstGeom prst="rect">
-            <a:avLst/>
-          </a:prstGeom>
-          <a:noFill/>
-          <a:ln/>
-        </p:spPr>
-        <p:txBody>
-          <a:bodyPr wrap="square" rtlCol="0" anchor="t">
-            <a:normAutofit/>
-          </a:bodyPr>
-          <a:lstStyle/>
-          <a:p>
-            <a:pPr algn="just" indent="0" marL="0">
-              <a:buNone/>
-            </a:pPr>
-            <a:r>
-              <a:rPr lang="en-US" sz="1700" dirty="0">
+              <a:rPr lang="en-US" sz="1900" dirty="0">
                 <a:solidFill>
                   <a:srgbClr val="1C2B2D"/>
                 </a:solidFill>
@@ -4681,124 +5007,62 @@
                 <a:ea typeface="Calibri" pitchFamily="34" charset="-122"/>
                 <a:cs typeface="Calibri" pitchFamily="34" charset="-120"/>
               </a:rPr>
-              <a:t>A list of food and drinks.</a:t>
-            </a:r>
-            <a:endParaRPr lang="en-US" sz="1700" dirty="0"/>
-          </a:p>
-        </p:txBody>
-      </p:sp>
-      <p:sp>
-        <p:nvSpPr>
-          <p:cNvPr id="7" name="Text 5"/>
-          <p:cNvSpPr/>
-          <p:nvPr/>
-        </p:nvSpPr>
-        <p:spPr>
-          <a:xfrm>
-            <a:off x="777240" y="3040380"/>
-            <a:ext cx="7589520" cy="594360"/>
-          </a:xfrm>
-          <a:prstGeom prst="rect">
-            <a:avLst/>
-          </a:prstGeom>
-          <a:noFill/>
-          <a:ln/>
-        </p:spPr>
-        <p:txBody>
-          <a:bodyPr wrap="square" rtlCol="0" anchor="ctr">
-            <a:normAutofit/>
-          </a:bodyPr>
-          <a:lstStyle/>
+              <a:t>What food and drink can you see?</a:t>
+            </a:r>
+            <a:endParaRPr lang="en-US" sz="1900" dirty="0"/>
+          </a:p>
           <a:p>
             <a:pPr algn="just" indent="0" marL="0">
+              <a:lnSpc>
+                <a:spcPct val="115000"/>
+              </a:lnSpc>
+              <a:spcAft>
+                <a:spcPts val="1200"/>
+              </a:spcAft>
               <a:buNone/>
             </a:pPr>
             <a:r>
-              <a:rPr lang="en-US" sz="1500" i="1" dirty="0">
-                <a:solidFill>
-                  <a:srgbClr val="6B7B79"/>
+              <a:rPr lang="en-US" sz="1900" dirty="0">
+                <a:solidFill>
+                  <a:srgbClr val="1C2B2D"/>
                 </a:solidFill>
                 <a:latin typeface="Calibri" pitchFamily="34" charset="0"/>
                 <a:ea typeface="Calibri" pitchFamily="34" charset="-122"/>
                 <a:cs typeface="Calibri" pitchFamily="34" charset="-120"/>
               </a:rPr>
-              <a:t>"Can I see the menu, please?"</a:t>
-            </a:r>
-            <a:endParaRPr lang="en-US" sz="1500" dirty="0"/>
-          </a:p>
-        </p:txBody>
-      </p:sp>
-      <p:sp>
-        <p:nvSpPr>
-          <p:cNvPr id="8" name="Shape 6"/>
-          <p:cNvSpPr/>
-          <p:nvPr/>
-        </p:nvSpPr>
-        <p:spPr>
-          <a:xfrm>
-            <a:off x="502920" y="3973068"/>
-            <a:ext cx="8138160" cy="731520"/>
-          </a:xfrm>
-          <a:prstGeom prst="roundRect">
-            <a:avLst>
-              <a:gd name="adj" fmla="val 10000"/>
-            </a:avLst>
-          </a:prstGeom>
-          <a:solidFill>
-            <a:srgbClr val="E3EFEC"/>
-          </a:solidFill>
-          <a:ln w="12700">
-            <a:solidFill>
-              <a:srgbClr val="0F766E"/>
-            </a:solidFill>
-            <a:prstDash val="solid"/>
-          </a:ln>
-        </p:spPr>
-      </p:sp>
-      <p:sp>
-        <p:nvSpPr>
-          <p:cNvPr id="9" name="Text 7"/>
-          <p:cNvSpPr/>
-          <p:nvPr/>
-        </p:nvSpPr>
-        <p:spPr>
-          <a:xfrm>
-            <a:off x="685800" y="4027932"/>
-            <a:ext cx="7772400" cy="621792"/>
-          </a:xfrm>
-          <a:prstGeom prst="rect">
-            <a:avLst/>
-          </a:prstGeom>
-          <a:noFill/>
-          <a:ln/>
-        </p:spPr>
-        <p:txBody>
-          <a:bodyPr wrap="square" rtlCol="0" anchor="ctr">
-            <a:normAutofit/>
-          </a:bodyPr>
-          <a:lstStyle/>
-          <a:p>
-            <a:pPr algn="just" indent="0" marL="0">
-              <a:buNone/>
-            </a:pPr>
-            <a:r>
-              <a:rPr lang="en-US" sz="1500" b="1" dirty="0">
-                <a:solidFill>
-                  <a:srgbClr val="10312B"/>
-                </a:solidFill>
-                <a:latin typeface="Calibri" pitchFamily="34" charset="0"/>
-                <a:ea typeface="Calibri" pitchFamily="34" charset="-122"/>
-                <a:cs typeface="Calibri" pitchFamily="34" charset="-120"/>
-              </a:rPr>
-              <a:t>Use the word in a new example.</a:t>
-            </a:r>
-            <a:endParaRPr lang="en-US" sz="1500" dirty="0"/>
-          </a:p>
-        </p:txBody>
-      </p:sp>
-      <p:sp>
-        <p:nvSpPr>
-          <p:cNvPr id="10" name="Text 8"/>
+              <a:t>Ask for them politely.</a:t>
+            </a:r>
+            <a:endParaRPr lang="en-US" sz="1900" dirty="0"/>
+          </a:p>
+        </p:txBody>
+      </p:sp>
+      <p:pic>
+        <p:nvPicPr>
+          <p:cNvPr id="6" name="Image 0" descr="preencoded.png">    </p:cNvPr>
+          <p:cNvPicPr>
+            <a:picLocks noChangeAspect="1"/>
+          </p:cNvPicPr>
+          <p:nvPr/>
+        </p:nvPicPr>
+        <p:blipFill>
+          <a:blip r:embed="rId1"/>
+          <a:stretch>
+            <a:fillRect/>
+          </a:stretch>
+        </p:blipFill>
+        <p:spPr>
+          <a:xfrm>
+            <a:off x="5334610" y="1835353"/>
+            <a:ext cx="3306470" cy="2204314"/>
+          </a:xfrm>
+          <a:prstGeom prst="rect">
+            <a:avLst/>
+          </a:prstGeom>
+        </p:spPr>
+      </p:pic>
+      <p:sp>
+        <p:nvSpPr>
+          <p:cNvPr id="7" name="Text 4"/>
           <p:cNvSpPr/>
           <p:nvPr/>
         </p:nvSpPr>
@@ -4922,7 +5186,7 @@
                 <a:ea typeface="Georgia" pitchFamily="34" charset="-122"/>
                 <a:cs typeface="Georgia" pitchFamily="34" charset="-120"/>
               </a:rPr>
-              <a:t>Order</a:t>
+              <a:t>Menu</a:t>
             </a:r>
             <a:endParaRPr lang="en-US" sz="3000" dirty="0"/>
           </a:p>
@@ -4988,7 +5252,7 @@
                 <a:ea typeface="Georgia" pitchFamily="34" charset="-122"/>
                 <a:cs typeface="Georgia" pitchFamily="34" charset="-120"/>
               </a:rPr>
-              <a:t>Order</a:t>
+              <a:t>Menu</a:t>
             </a:r>
             <a:endParaRPr lang="en-US" sz="3400" dirty="0"/>
           </a:p>
@@ -5029,7 +5293,7 @@
                 <a:ea typeface="Calibri" pitchFamily="34" charset="-122"/>
                 <a:cs typeface="Calibri" pitchFamily="34" charset="-120"/>
               </a:rPr>
-              <a:t>Ask for food or drinks.</a:t>
+              <a:t>A list of food and drinks.</a:t>
             </a:r>
             <a:endParaRPr lang="en-US" sz="1700" dirty="0"/>
           </a:p>
@@ -5070,7 +5334,7 @@
                 <a:ea typeface="Calibri" pitchFamily="34" charset="-122"/>
                 <a:cs typeface="Calibri" pitchFamily="34" charset="-120"/>
               </a:rPr>
-              <a:t>"I would like to order."</a:t>
+              <a:t>"Can I see the menu, please?"</a:t>
             </a:r>
             <a:endParaRPr lang="en-US" sz="1500" dirty="0"/>
           </a:p>
@@ -5270,7 +5534,7 @@
                 <a:ea typeface="Georgia" pitchFamily="34" charset="-122"/>
                 <a:cs typeface="Georgia" pitchFamily="34" charset="-120"/>
               </a:rPr>
-              <a:t>Water</a:t>
+              <a:t>Order</a:t>
             </a:r>
             <a:endParaRPr lang="en-US" sz="3000" dirty="0"/>
           </a:p>
@@ -5336,7 +5600,7 @@
                 <a:ea typeface="Georgia" pitchFamily="34" charset="-122"/>
                 <a:cs typeface="Georgia" pitchFamily="34" charset="-120"/>
               </a:rPr>
-              <a:t>Water</a:t>
+              <a:t>Order</a:t>
             </a:r>
             <a:endParaRPr lang="en-US" sz="3400" dirty="0"/>
           </a:p>
@@ -5377,7 +5641,7 @@
                 <a:ea typeface="Calibri" pitchFamily="34" charset="-122"/>
                 <a:cs typeface="Calibri" pitchFamily="34" charset="-120"/>
               </a:rPr>
-              <a:t>A drink.</a:t>
+              <a:t>Ask for food or drinks.</a:t>
             </a:r>
             <a:endParaRPr lang="en-US" sz="1700" dirty="0"/>
           </a:p>
@@ -5418,7 +5682,7 @@
                 <a:ea typeface="Calibri" pitchFamily="34" charset="-122"/>
                 <a:cs typeface="Calibri" pitchFamily="34" charset="-120"/>
               </a:rPr>
-              <a:t>"Still water, please."</a:t>
+              <a:t>"I would like to order."</a:t>
             </a:r>
             <a:endParaRPr lang="en-US" sz="1500" dirty="0"/>
           </a:p>
@@ -5618,7 +5882,7 @@
                 <a:ea typeface="Georgia" pitchFamily="34" charset="-122"/>
                 <a:cs typeface="Georgia" pitchFamily="34" charset="-120"/>
               </a:rPr>
-              <a:t>Chicken</a:t>
+              <a:t>Water</a:t>
             </a:r>
             <a:endParaRPr lang="en-US" sz="3000" dirty="0"/>
           </a:p>
@@ -5684,7 +5948,7 @@
                 <a:ea typeface="Georgia" pitchFamily="34" charset="-122"/>
                 <a:cs typeface="Georgia" pitchFamily="34" charset="-120"/>
               </a:rPr>
-              <a:t>Chicken</a:t>
+              <a:t>Water</a:t>
             </a:r>
             <a:endParaRPr lang="en-US" sz="3400" dirty="0"/>
           </a:p>
@@ -5725,7 +5989,7 @@
                 <a:ea typeface="Calibri" pitchFamily="34" charset="-122"/>
                 <a:cs typeface="Calibri" pitchFamily="34" charset="-120"/>
               </a:rPr>
-              <a:t>A type of meat.</a:t>
+              <a:t>A drink.</a:t>
             </a:r>
             <a:endParaRPr lang="en-US" sz="1700" dirty="0"/>
           </a:p>
@@ -5766,7 +6030,7 @@
                 <a:ea typeface="Calibri" pitchFamily="34" charset="-122"/>
                 <a:cs typeface="Calibri" pitchFamily="34" charset="-120"/>
               </a:rPr>
-              <a:t>"I would like the chicken."</a:t>
+              <a:t>"Still water, please."</a:t>
             </a:r>
             <a:endParaRPr lang="en-US" sz="1500" dirty="0"/>
           </a:p>
@@ -5966,7 +6230,7 @@
                 <a:ea typeface="Georgia" pitchFamily="34" charset="-122"/>
                 <a:cs typeface="Georgia" pitchFamily="34" charset="-120"/>
               </a:rPr>
-              <a:t>Bill</a:t>
+              <a:t>Chicken</a:t>
             </a:r>
             <a:endParaRPr lang="en-US" sz="3000" dirty="0"/>
           </a:p>
@@ -6032,7 +6296,7 @@
                 <a:ea typeface="Georgia" pitchFamily="34" charset="-122"/>
                 <a:cs typeface="Georgia" pitchFamily="34" charset="-120"/>
               </a:rPr>
-              <a:t>Bill</a:t>
+              <a:t>Chicken</a:t>
             </a:r>
             <a:endParaRPr lang="en-US" sz="3400" dirty="0"/>
           </a:p>
@@ -6073,7 +6337,7 @@
                 <a:ea typeface="Calibri" pitchFamily="34" charset="-122"/>
                 <a:cs typeface="Calibri" pitchFamily="34" charset="-120"/>
               </a:rPr>
-              <a:t>The list of what you need to pay.</a:t>
+              <a:t>A type of meat.</a:t>
             </a:r>
             <a:endParaRPr lang="en-US" sz="1700" dirty="0"/>
           </a:p>
@@ -6114,7 +6378,7 @@
                 <a:ea typeface="Calibri" pitchFamily="34" charset="-122"/>
                 <a:cs typeface="Calibri" pitchFamily="34" charset="-120"/>
               </a:rPr>
-              <a:t>"Can I have the bill, please?"</a:t>
+              <a:t>"I would like the chicken."</a:t>
             </a:r>
             <a:endParaRPr lang="en-US" sz="1500" dirty="0"/>
           </a:p>
@@ -6314,7 +6578,7 @@
                 <a:ea typeface="Georgia" pitchFamily="34" charset="-122"/>
                 <a:cs typeface="Georgia" pitchFamily="34" charset="-120"/>
               </a:rPr>
-              <a:t>Read and notice</a:t>
+              <a:t>Bill</a:t>
             </a:r>
             <a:endParaRPr lang="en-US" sz="3000" dirty="0"/>
           </a:p>
@@ -6353,32 +6617,67 @@
         </p:nvSpPr>
         <p:spPr>
           <a:xfrm>
-            <a:off x="777240" y="1435608"/>
-            <a:ext cx="7589520" cy="2180844"/>
-          </a:xfrm>
-          <a:prstGeom prst="rect">
-            <a:avLst/>
-          </a:prstGeom>
-          <a:noFill/>
-          <a:ln/>
-        </p:spPr>
-        <p:txBody>
-          <a:bodyPr wrap="square" lIns="0" tIns="0" rIns="0" bIns="0" rtlCol="0" anchor="t">
+            <a:off x="777240" y="1399032"/>
+            <a:ext cx="7589520" cy="685800"/>
+          </a:xfrm>
+          <a:prstGeom prst="rect">
+            <a:avLst/>
+          </a:prstGeom>
+          <a:noFill/>
+          <a:ln/>
+        </p:spPr>
+        <p:txBody>
+          <a:bodyPr wrap="square" rtlCol="0" anchor="ctr">
             <a:normAutofit/>
           </a:bodyPr>
           <a:lstStyle/>
           <a:p>
+            <a:pPr indent="0" marL="0">
+              <a:buNone/>
+            </a:pPr>
+            <a:r>
+              <a:rPr lang="en-US" sz="3400" b="1" dirty="0">
+                <a:solidFill>
+                  <a:srgbClr val="C1272D"/>
+                </a:solidFill>
+                <a:latin typeface="Georgia" pitchFamily="34" charset="0"/>
+                <a:ea typeface="Georgia" pitchFamily="34" charset="-122"/>
+                <a:cs typeface="Georgia" pitchFamily="34" charset="-120"/>
+              </a:rPr>
+              <a:t>Bill</a:t>
+            </a:r>
+            <a:endParaRPr lang="en-US" sz="3400" dirty="0"/>
+          </a:p>
+        </p:txBody>
+      </p:sp>
+      <p:sp>
+        <p:nvSpPr>
+          <p:cNvPr id="6" name="Text 4"/>
+          <p:cNvSpPr/>
+          <p:nvPr/>
+        </p:nvSpPr>
+        <p:spPr>
+          <a:xfrm>
+            <a:off x="777240" y="2148840"/>
+            <a:ext cx="7589520" cy="845820"/>
+          </a:xfrm>
+          <a:prstGeom prst="rect">
+            <a:avLst/>
+          </a:prstGeom>
+          <a:noFill/>
+          <a:ln/>
+        </p:spPr>
+        <p:txBody>
+          <a:bodyPr wrap="square" rtlCol="0" anchor="t">
+            <a:normAutofit/>
+          </a:bodyPr>
+          <a:lstStyle/>
+          <a:p>
             <a:pPr algn="just" indent="0" marL="0">
-              <a:lnSpc>
-                <a:spcPct val="115000"/>
-              </a:lnSpc>
-              <a:spcAft>
-                <a:spcPts val="1200"/>
-              </a:spcAft>
               <a:buNone/>
             </a:pPr>
             <a:r>
-              <a:rPr lang="en-US" sz="1900" dirty="0">
+              <a:rPr lang="en-US" sz="1700" dirty="0">
                 <a:solidFill>
                   <a:srgbClr val="1C2B2D"/>
                 </a:solidFill>
@@ -6386,15 +6685,56 @@
                 <a:ea typeface="Calibri" pitchFamily="34" charset="-122"/>
                 <a:cs typeface="Calibri" pitchFamily="34" charset="-120"/>
               </a:rPr>
-              <a:t>Lunch at Cedar Café</a:t>
-            </a:r>
-            <a:endParaRPr lang="en-US" sz="1900" dirty="0"/>
-          </a:p>
-        </p:txBody>
-      </p:sp>
-      <p:sp>
-        <p:nvSpPr>
-          <p:cNvPr id="6" name="Shape 4"/>
+              <a:t>The list of what you need to pay.</a:t>
+            </a:r>
+            <a:endParaRPr lang="en-US" sz="1700" dirty="0"/>
+          </a:p>
+        </p:txBody>
+      </p:sp>
+      <p:sp>
+        <p:nvSpPr>
+          <p:cNvPr id="7" name="Text 5"/>
+          <p:cNvSpPr/>
+          <p:nvPr/>
+        </p:nvSpPr>
+        <p:spPr>
+          <a:xfrm>
+            <a:off x="777240" y="3040380"/>
+            <a:ext cx="7589520" cy="594360"/>
+          </a:xfrm>
+          <a:prstGeom prst="rect">
+            <a:avLst/>
+          </a:prstGeom>
+          <a:noFill/>
+          <a:ln/>
+        </p:spPr>
+        <p:txBody>
+          <a:bodyPr wrap="square" rtlCol="0" anchor="ctr">
+            <a:normAutofit/>
+          </a:bodyPr>
+          <a:lstStyle/>
+          <a:p>
+            <a:pPr algn="just" indent="0" marL="0">
+              <a:buNone/>
+            </a:pPr>
+            <a:r>
+              <a:rPr lang="en-US" sz="1500" i="1" dirty="0">
+                <a:solidFill>
+                  <a:srgbClr val="6B7B79"/>
+                </a:solidFill>
+                <a:latin typeface="Calibri" pitchFamily="34" charset="0"/>
+                <a:ea typeface="Calibri" pitchFamily="34" charset="-122"/>
+                <a:cs typeface="Calibri" pitchFamily="34" charset="-120"/>
+              </a:rPr>
+              <a:t>"Can I have the bill, please?"</a:t>
+            </a:r>
+            <a:endParaRPr lang="en-US" sz="1500" dirty="0"/>
+          </a:p>
+        </p:txBody>
+      </p:sp>
+      <p:sp>
+        <p:nvSpPr>
+          <p:cNvPr id="8" name="Shape 6"/>
           <p:cNvSpPr/>
           <p:nvPr/>
         </p:nvSpPr>
@@ -6421,7 +6761,7 @@
       </p:sp>
       <p:sp>
         <p:nvSpPr>
-          <p:cNvPr id="7" name="Text 5"/>
+          <p:cNvPr id="9" name="Text 7"/>
           <p:cNvSpPr/>
           <p:nvPr/>
         </p:nvSpPr>
@@ -6454,7 +6794,7 @@
                 <a:ea typeface="Calibri" pitchFamily="34" charset="-122"/>
                 <a:cs typeface="Calibri" pitchFamily="34" charset="-120"/>
               </a:rPr>
-              <a:t>Which food is unavailable?</a:t>
+              <a:t>Use the word in a new example.</a:t>
             </a:r>
             <a:endParaRPr lang="en-US" sz="1500" dirty="0"/>
           </a:p>
@@ -6462,7 +6802,7 @@
       </p:sp>
       <p:sp>
         <p:nvSpPr>
-          <p:cNvPr id="8" name="Text 6"/>
+          <p:cNvPr id="10" name="Text 8"/>
           <p:cNvSpPr/>
           <p:nvPr/>
         </p:nvSpPr>

</xml_diff>